<commit_message>
docs: update stage3 weekly report with stage5 findings
</commit_message>
<xml_diff>
--- a/docs/presentations/ascr_stage3_weekly_report.pptx
+++ b/docs/presentations/ascr_stage3_weekly_report.pptx
@@ -18,6 +18,7 @@
     <p:sldId id="266" r:id="rId17"/>
     <p:sldId id="267" r:id="rId18"/>
     <p:sldId id="268" r:id="rId19"/>
+    <p:sldId id="269" r:id="rId20"/>
   </p:sldIdLst>
   <p:sldSz cx="12191695" cy="6858000" type="screen4x3"/>
   <p:notesSz cx="6858000" cy="9144000"/>
@@ -3663,7 +3664,7 @@
                 </a:solidFill>
                 <a:latin typeface="Aptos"/>
               </a:rPr>
-              <a:t>Only after a useful selector or LoRA localizer</a:t>
+              <a:t>Engineering loop now runs; localizer quality is the bottleneck</a:t>
             </a:r>
           </a:p>
         </p:txBody>
@@ -4186,7 +4187,7 @@
             <a:avLst/>
           </a:prstGeom>
           <a:solidFill>
-            <a:srgbClr val="426792"/>
+            <a:srgbClr val="588760"/>
           </a:solidFill>
           <a:ln>
             <a:noFill/>
@@ -4243,7 +4244,7 @@
                 </a:solidFill>
                 <a:latin typeface="Aptos"/>
               </a:rPr>
-              <a:t>Initial policy</a:t>
+              <a:t>New evidence</a:t>
             </a:r>
           </a:p>
           <a:p>
@@ -4259,7 +4260,7 @@
               </a:defRPr>
             </a:pPr>
             <a:r>
-              <a:t>If mask empty: stop</a:t>
+              <a:t>Single-sample smoke completed: 161923</a:t>
             </a:r>
           </a:p>
           <a:p>
@@ -4275,7 +4276,7 @@
               </a:defRPr>
             </a:pPr>
             <a:r>
-              <a:t>If mask nonempty: reopen selected cells</a:t>
+              <a:t>2-sample benchmark completed: 161943</a:t>
             </a:r>
           </a:p>
           <a:p>
@@ -4291,7 +4292,7 @@
               </a:defRPr>
             </a:pPr>
             <a:r>
-              <a:t>Add scorer only after nontrivial masks</a:t>
+              <a:t>ok_count=2, error_count=0</a:t>
             </a:r>
           </a:p>
         </p:txBody>
@@ -4356,7 +4357,7 @@
             <a:avLst/>
           </a:prstGeom>
           <a:solidFill>
-            <a:srgbClr val="4E817C"/>
+            <a:srgbClr val="9E5B5B"/>
           </a:solidFill>
           <a:ln>
             <a:noFill/>
@@ -4413,7 +4414,7 @@
                 </a:solidFill>
                 <a:latin typeface="Aptos"/>
               </a:rPr>
-              <a:t>Artifacts to keep</a:t>
+              <a:t>But localizer failed</a:t>
             </a:r>
           </a:p>
           <a:p>
@@ -4429,7 +4430,7 @@
               </a:defRPr>
             </a:pPr>
             <a:r>
-              <a:t>Trace and selected indices</a:t>
+              <a:t>target=B5 in both samples</a:t>
             </a:r>
           </a:p>
           <a:p>
@@ -4445,7 +4446,7 @@
               </a:defRPr>
             </a:pPr>
             <a:r>
-              <a:t>Selected token/cell count</a:t>
+              <a:t>LoRA predicted D/F/G rows</a:t>
             </a:r>
           </a:p>
           <a:p>
@@ -4461,23 +4462,7 @@
               </a:defRPr>
             </a:pPr>
             <a:r>
-              <a:t>Decoded before/after images</a:t>
-            </a:r>
-          </a:p>
-          <a:p>
-            <a:pPr>
-              <a:spcBef>
-                <a:spcPts val="600"/>
-              </a:spcBef>
-              <a:defRPr sz="1100">
-                <a:solidFill>
-                  <a:srgbClr val="465260"/>
-                </a:solidFill>
-                <a:latin typeface="Aptos"/>
-              </a:defRPr>
-            </a:pPr>
-            <a:r>
-              <a:t>Final summary metrics</a:t>
+              <a:t>hit_any=0/2 despite reopen_changed=1.0</a:t>
             </a:r>
           </a:p>
         </p:txBody>
@@ -4573,7 +4558,7 @@
                 </a:solidFill>
                 <a:latin typeface="Aptos"/>
               </a:rPr>
-              <a:t>This Week's Deliverables / 本周完成</a:t>
+              <a:t>Stage-5 Result: Working Loop, Failed Native Localizer</a:t>
             </a:r>
           </a:p>
         </p:txBody>
@@ -4608,7 +4593,7 @@
                 </a:solidFill>
                 <a:latin typeface="Aptos"/>
               </a:rPr>
-              <a:t>Evidence-backed summary</a:t>
+              <a:t>The result is useful as a negative baseline, not as the final selector</a:t>
             </a:r>
           </a:p>
         </p:txBody>
@@ -4664,8 +4649,8 @@
         </p:nvSpPr>
         <p:spPr>
           <a:xfrm>
-            <a:off x="731520" y="1417320"/>
-            <a:ext cx="3383280" cy="3108960"/>
+            <a:off x="731520" y="1325880"/>
+            <a:ext cx="3383280" cy="3246120"/>
           </a:xfrm>
           <a:prstGeom prst="roundRect">
             <a:avLst/>
@@ -4709,14 +4694,14 @@
         </p:nvSpPr>
         <p:spPr>
           <a:xfrm>
-            <a:off x="731520" y="1417320"/>
-            <a:ext cx="73152" cy="3108960"/>
+            <a:off x="731520" y="1325880"/>
+            <a:ext cx="73152" cy="3246120"/>
           </a:xfrm>
           <a:prstGeom prst="rect">
             <a:avLst/>
           </a:prstGeom>
           <a:solidFill>
-            <a:srgbClr val="426792"/>
+            <a:srgbClr val="588760"/>
           </a:solidFill>
           <a:ln>
             <a:noFill/>
@@ -4752,8 +4737,8 @@
         </p:nvSpPr>
         <p:spPr>
           <a:xfrm>
-            <a:off x="932688" y="1581912"/>
-            <a:ext cx="2999232" cy="2880360"/>
+            <a:off x="932688" y="1490472"/>
+            <a:ext cx="2999232" cy="3017520"/>
           </a:xfrm>
           <a:prstGeom prst="rect">
             <a:avLst/>
@@ -4773,7 +4758,7 @@
                 </a:solidFill>
                 <a:latin typeface="Aptos"/>
               </a:rPr>
-              <a:t>Research design</a:t>
+              <a:t>What succeeded</a:t>
             </a:r>
           </a:p>
           <a:p>
@@ -4789,7 +4774,7 @@
               </a:defRPr>
             </a:pPr>
             <a:r>
-              <a:t>Stage 3 scoped to discrete-token corruption</a:t>
+              <a:t>clean/corrupt/reopen/decode path runs</a:t>
             </a:r>
           </a:p>
           <a:p>
@@ -4805,7 +4790,7 @@
               </a:defRPr>
             </a:pPr>
             <a:r>
-              <a:t>Phase 0-5 roadmap clarified</a:t>
+              <a:t>LoRA answer path no longer crashes</a:t>
             </a:r>
           </a:p>
           <a:p>
@@ -4821,7 +4806,7 @@
               </a:defRPr>
             </a:pPr>
             <a:r>
-              <a:t>Training labels defined from token masks</a:t>
+              <a:t>Artifacts: trace, masks, before/after images</a:t>
             </a:r>
           </a:p>
         </p:txBody>
@@ -4834,8 +4819,8 @@
         </p:nvSpPr>
         <p:spPr>
           <a:xfrm>
-            <a:off x="4434840" y="1417320"/>
-            <a:ext cx="3383280" cy="3108960"/>
+            <a:off x="4434840" y="1325880"/>
+            <a:ext cx="3383280" cy="3246120"/>
           </a:xfrm>
           <a:prstGeom prst="roundRect">
             <a:avLst/>
@@ -4879,14 +4864,14 @@
         </p:nvSpPr>
         <p:spPr>
           <a:xfrm>
-            <a:off x="4434840" y="1417320"/>
-            <a:ext cx="73152" cy="3108960"/>
+            <a:off x="4434840" y="1325880"/>
+            <a:ext cx="73152" cy="3246120"/>
           </a:xfrm>
           <a:prstGeom prst="rect">
             <a:avLst/>
           </a:prstGeom>
           <a:solidFill>
-            <a:srgbClr val="4E817C"/>
+            <a:srgbClr val="9E5B5B"/>
           </a:solidFill>
           <a:ln>
             <a:noFill/>
@@ -4922,8 +4907,8 @@
         </p:nvSpPr>
         <p:spPr>
           <a:xfrm>
-            <a:off x="4636008" y="1581912"/>
-            <a:ext cx="2999232" cy="2880360"/>
+            <a:off x="4636008" y="1490472"/>
+            <a:ext cx="2999232" cy="3017520"/>
           </a:xfrm>
           <a:prstGeom prst="rect">
             <a:avLst/>
@@ -4943,7 +4928,7 @@
                 </a:solidFill>
                 <a:latin typeface="Aptos"/>
               </a:rPr>
-              <a:t>Pipeline</a:t>
+              <a:t>What failed</a:t>
             </a:r>
           </a:p>
           <a:p>
@@ -4959,7 +4944,7 @@
               </a:defRPr>
             </a:pPr>
             <a:r>
-              <a:t>Clean-token generation path</a:t>
+              <a:t>raw MMU text is malformed/repetitive</a:t>
             </a:r>
           </a:p>
           <a:p>
@@ -4975,7 +4960,7 @@
               </a:defRPr>
             </a:pPr>
             <a:r>
-              <a:t>Repair dataset config: 40k rows target</a:t>
+              <a:t>parser recovers cells but not meaning</a:t>
             </a:r>
           </a:p>
           <a:p>
@@ -4991,7 +4976,7 @@
               </a:defRPr>
             </a:pPr>
             <a:r>
-              <a:t>SFT conversion and LoRA runners</a:t>
+              <a:t>selected cells miss true target</a:t>
             </a:r>
           </a:p>
         </p:txBody>
@@ -5004,8 +4989,8 @@
         </p:nvSpPr>
         <p:spPr>
           <a:xfrm>
-            <a:off x="8138160" y="1417320"/>
-            <a:ext cx="3383280" cy="3108960"/>
+            <a:off x="8138160" y="1325880"/>
+            <a:ext cx="3383280" cy="3246120"/>
           </a:xfrm>
           <a:prstGeom prst="roundRect">
             <a:avLst/>
@@ -5049,8 +5034,8 @@
         </p:nvSpPr>
         <p:spPr>
           <a:xfrm>
-            <a:off x="8138160" y="1417320"/>
-            <a:ext cx="73152" cy="3108960"/>
+            <a:off x="8138160" y="1325880"/>
+            <a:ext cx="73152" cy="3246120"/>
           </a:xfrm>
           <a:prstGeom prst="rect">
             <a:avLst/>
@@ -5092,8 +5077,8 @@
         </p:nvSpPr>
         <p:spPr>
           <a:xfrm>
-            <a:off x="8339328" y="1581912"/>
-            <a:ext cx="2999232" cy="2880360"/>
+            <a:off x="8339328" y="1490472"/>
+            <a:ext cx="2999232" cy="3017520"/>
           </a:xfrm>
           <a:prstGeom prst="rect">
             <a:avLst/>
@@ -5113,7 +5098,7 @@
                 </a:solidFill>
                 <a:latin typeface="Aptos"/>
               </a:rPr>
-              <a:t>Validation gates</a:t>
+              <a:t>How to report it</a:t>
             </a:r>
           </a:p>
           <a:p>
@@ -5129,7 +5114,7 @@
               </a:defRPr>
             </a:pPr>
             <a:r>
-              <a:t>Locality smoke passed</a:t>
+              <a:t>Current LoRA = failed baseline</a:t>
             </a:r>
           </a:p>
           <a:p>
@@ -5145,7 +5130,7 @@
               </a:defRPr>
             </a:pPr>
             <a:r>
-              <a:t>Hard64 selector baseline gate cleared</a:t>
+              <a:t>Do not claim repair quality yet</a:t>
             </a:r>
           </a:p>
           <a:p>
@@ -5161,7 +5146,7 @@
               </a:defRPr>
             </a:pPr>
             <a:r>
-              <a:t>Phase 4 not yet fully cleared</a:t>
+              <a:t>Use as evidence for stronger supervision</a:t>
             </a:r>
           </a:p>
         </p:txBody>
@@ -5174,8 +5159,8 @@
         </p:nvSpPr>
         <p:spPr>
           <a:xfrm>
-            <a:off x="914400" y="5074920"/>
-            <a:ext cx="10058400" cy="502920"/>
+            <a:off x="822960" y="4983480"/>
+            <a:ext cx="10607040" cy="640080"/>
           </a:xfrm>
           <a:prstGeom prst="rect">
             <a:avLst/>
@@ -5192,11 +5177,11 @@
             <a:r>
               <a:rPr sz="1300" b="0">
                 <a:solidFill>
-                  <a:srgbClr val="697380"/>
+                  <a:srgbClr val="203044"/>
                 </a:solidFill>
                 <a:latin typeface="Aptos"/>
               </a:rPr>
-              <a:t>No formal before/after image-quality result is claimed here unless already recorded in the repository.</a:t>
+              <a:t>Interpretation: Stage 5 infrastructure is validated; Stage 4 native localizer is the research bottleneck.</a:t>
             </a:r>
           </a:p>
         </p:txBody>
@@ -5292,7 +5277,7 @@
                 </a:solidFill>
                 <a:latin typeface="Aptos"/>
               </a:rPr>
-              <a:t>Next Actions / 下一步</a:t>
+              <a:t>Decision Point: Add Oracle + Stage-2 Image-Space Teacher</a:t>
             </a:r>
           </a:p>
         </p:txBody>
@@ -5327,7 +5312,7 @@
                 </a:solidFill>
                 <a:latin typeface="Aptos"/>
               </a:rPr>
-              <a:t>Concrete server continuation</a:t>
+              <a:t>Do not abandon Stage 3 yet; isolate whether the bottleneck is localizer or reopen</a:t>
             </a:r>
           </a:p>
         </p:txBody>
@@ -5384,7 +5369,7 @@
         <p:spPr>
           <a:xfrm>
             <a:off x="731520" y="1325880"/>
-            <a:ext cx="5120640" cy="2011680"/>
+            <a:ext cx="5120640" cy="2194560"/>
           </a:xfrm>
           <a:prstGeom prst="roundRect">
             <a:avLst/>
@@ -5429,7 +5414,7 @@
         <p:spPr>
           <a:xfrm>
             <a:off x="731520" y="1325880"/>
-            <a:ext cx="73152" cy="2011680"/>
+            <a:ext cx="73152" cy="2194560"/>
           </a:xfrm>
           <a:prstGeom prst="rect">
             <a:avLst/>
@@ -5472,7 +5457,7 @@
         <p:spPr>
           <a:xfrm>
             <a:off x="932688" y="1490472"/>
-            <a:ext cx="4736592" cy="1783080"/>
+            <a:ext cx="4736592" cy="1965960"/>
           </a:xfrm>
           <a:prstGeom prst="rect">
             <a:avLst/>
@@ -5492,7 +5477,7 @@
                 </a:solidFill>
                 <a:latin typeface="Aptos"/>
               </a:rPr>
-              <a:t>Short-term</a:t>
+              <a:t>Oracle upper bound</a:t>
             </a:r>
           </a:p>
           <a:p>
@@ -5508,7 +5493,7 @@
               </a:defRPr>
             </a:pPr>
             <a:r>
-              <a:t>Generate/verify clean tokens</a:t>
+              <a:t>Use true target_cells directly</a:t>
             </a:r>
           </a:p>
           <a:p>
@@ -5524,7 +5509,7 @@
               </a:defRPr>
             </a:pPr>
             <a:r>
-              <a:t>Build repair_cells_40k dataset</a:t>
+              <a:t>Same prompt/corruption/reopen path</a:t>
             </a:r>
           </a:p>
           <a:p>
@@ -5540,7 +5525,23 @@
               </a:defRPr>
             </a:pPr>
             <a:r>
-              <a:t>Prepare SFT and convert Lumina JSONL</a:t>
+              <a:t>If oracle fails: generator/reopen problem</a:t>
+            </a:r>
+          </a:p>
+          <a:p>
+            <a:pPr>
+              <a:spcBef>
+                <a:spcPts val="600"/>
+              </a:spcBef>
+              <a:defRPr sz="1100">
+                <a:solidFill>
+                  <a:srgbClr val="465260"/>
+                </a:solidFill>
+                <a:latin typeface="Aptos"/>
+              </a:defRPr>
+            </a:pPr>
+            <a:r>
+              <a:t>If oracle works: localizer problem</a:t>
             </a:r>
           </a:p>
         </p:txBody>
@@ -5554,7 +5555,7 @@
         <p:spPr>
           <a:xfrm>
             <a:off x="6309360" y="1325880"/>
-            <a:ext cx="5120640" cy="2011680"/>
+            <a:ext cx="5120640" cy="2194560"/>
           </a:xfrm>
           <a:prstGeom prst="roundRect">
             <a:avLst/>
@@ -5599,7 +5600,7 @@
         <p:spPr>
           <a:xfrm>
             <a:off x="6309360" y="1325880"/>
-            <a:ext cx="73152" cy="2011680"/>
+            <a:ext cx="73152" cy="2194560"/>
           </a:xfrm>
           <a:prstGeom prst="rect">
             <a:avLst/>
@@ -5642,7 +5643,7 @@
         <p:spPr>
           <a:xfrm>
             <a:off x="6510528" y="1490472"/>
-            <a:ext cx="4736592" cy="1783080"/>
+            <a:ext cx="4736592" cy="1965960"/>
           </a:xfrm>
           <a:prstGeom prst="rect">
             <a:avLst/>
@@ -5662,7 +5663,7 @@
                 </a:solidFill>
                 <a:latin typeface="Aptos"/>
               </a:rPr>
-              <a:t>Training gate</a:t>
+              <a:t>Stage-2 style branch</a:t>
             </a:r>
           </a:p>
           <a:p>
@@ -5678,7 +5679,7 @@
               </a:defRPr>
             </a:pPr>
             <a:r>
-              <a:t>Train one authoritative LoRA adapter</a:t>
+              <a:t>External API analyzes decoded images</a:t>
             </a:r>
           </a:p>
           <a:p>
@@ -5694,7 +5695,7 @@
               </a:defRPr>
             </a:pPr>
             <a:r>
-              <a:t>Probe parse_rate first</a:t>
+              <a:t>Image-space evaluator/localizer, not VQ-token input</a:t>
             </a:r>
           </a:p>
           <a:p>
@@ -5710,7 +5711,23 @@
               </a:defRPr>
             </a:pPr>
             <a:r>
-              <a:t>Only interpret hit_any / IoU after parse is reliable</a:t>
+              <a:t>Use as teacher/control loop</a:t>
+            </a:r>
+          </a:p>
+          <a:p>
+            <a:pPr>
+              <a:spcBef>
+                <a:spcPts val="600"/>
+              </a:spcBef>
+              <a:defRPr sz="1100">
+                <a:solidFill>
+                  <a:srgbClr val="465260"/>
+                </a:solidFill>
+                <a:latin typeface="Aptos"/>
+              </a:defRPr>
+            </a:pPr>
+            <a:r>
+              <a:t>Compare to native LoRA selector</a:t>
             </a:r>
           </a:p>
         </p:txBody>
@@ -5723,8 +5740,8 @@
         </p:nvSpPr>
         <p:spPr>
           <a:xfrm>
-            <a:off x="731520" y="3794760"/>
-            <a:ext cx="10698480" cy="1325880"/>
+            <a:off x="731520" y="4069080"/>
+            <a:ext cx="10698480" cy="1051560"/>
           </a:xfrm>
           <a:prstGeom prst="roundRect">
             <a:avLst/>
@@ -5768,8 +5785,8 @@
         </p:nvSpPr>
         <p:spPr>
           <a:xfrm>
-            <a:off x="731520" y="3794760"/>
-            <a:ext cx="73152" cy="1325880"/>
+            <a:off x="731520" y="4069080"/>
+            <a:ext cx="73152" cy="1051560"/>
           </a:xfrm>
           <a:prstGeom prst="rect">
             <a:avLst/>
@@ -5811,8 +5828,8 @@
         </p:nvSpPr>
         <p:spPr>
           <a:xfrm>
-            <a:off x="932688" y="3959352"/>
-            <a:ext cx="10314432" cy="1097280"/>
+            <a:off x="932688" y="4233672"/>
+            <a:ext cx="10314432" cy="822960"/>
           </a:xfrm>
           <a:prstGeom prst="rect">
             <a:avLst/>
@@ -5832,7 +5849,7 @@
                 </a:solidFill>
                 <a:latin typeface="Aptos"/>
               </a:rPr>
-              <a:t>Open risk</a:t>
+              <a:t>Recommendation</a:t>
             </a:r>
           </a:p>
           <a:p>
@@ -5848,7 +5865,7 @@
               </a:defRPr>
             </a:pPr>
             <a:r>
-              <a:t>If 8-GPU 1024px LoRA OOMs, inspect DDP log and use H200/L40S fallback profiles; do not train many independent adapters and merge them.</a:t>
+              <a:t>Keep token-repair Stage 3 as main experimental scaffold, but add image-space external-teacher loop as an upper-bound/control path before more native-localizer training.</a:t>
             </a:r>
           </a:p>
         </p:txBody>
@@ -5944,7 +5961,7 @@
                 </a:solidFill>
                 <a:latin typeface="Aptos"/>
               </a:rPr>
-              <a:t>Evidence Sources / 依据文件</a:t>
+              <a:t>Next Actions / 下一步</a:t>
             </a:r>
           </a:p>
         </p:txBody>
@@ -5979,7 +5996,7 @@
                 </a:solidFill>
                 <a:latin typeface="Aptos"/>
               </a:rPr>
-              <a:t>Repository files used to avoid unsupported claims</a:t>
+              <a:t>Concrete server continuation</a:t>
             </a:r>
           </a:p>
         </p:txBody>
@@ -6036,7 +6053,7 @@
         <p:spPr>
           <a:xfrm>
             <a:off x="731520" y="1325880"/>
-            <a:ext cx="10698480" cy="3886200"/>
+            <a:ext cx="5120640" cy="2011680"/>
           </a:xfrm>
           <a:prstGeom prst="roundRect">
             <a:avLst/>
@@ -6081,6 +6098,658 @@
         <p:spPr>
           <a:xfrm>
             <a:off x="731520" y="1325880"/>
+            <a:ext cx="73152" cy="2011680"/>
+          </a:xfrm>
+          <a:prstGeom prst="rect">
+            <a:avLst/>
+          </a:prstGeom>
+          <a:solidFill>
+            <a:srgbClr val="426792"/>
+          </a:solidFill>
+          <a:ln>
+            <a:noFill/>
+          </a:ln>
+        </p:spPr>
+        <p:style>
+          <a:lnRef idx="1">
+            <a:schemeClr val="accent1"/>
+          </a:lnRef>
+          <a:fillRef idx="3">
+            <a:schemeClr val="accent1"/>
+          </a:fillRef>
+          <a:effectRef idx="2">
+            <a:schemeClr val="accent1"/>
+          </a:effectRef>
+          <a:fontRef idx="minor">
+            <a:schemeClr val="lt1"/>
+          </a:fontRef>
+        </p:style>
+        <p:txBody>
+          <a:bodyPr rtlCol="0" anchor="ctr"/>
+          <a:lstStyle/>
+          <a:p>
+            <a:pPr algn="ctr"/>
+          </a:p>
+        </p:txBody>
+      </p:sp>
+      <p:sp>
+        <p:nvSpPr>
+          <p:cNvPr id="7" name="TextBox 6"/>
+          <p:cNvSpPr txBox="1"/>
+          <p:nvPr/>
+        </p:nvSpPr>
+        <p:spPr>
+          <a:xfrm>
+            <a:off x="932688" y="1490472"/>
+            <a:ext cx="4736592" cy="1783080"/>
+          </a:xfrm>
+          <a:prstGeom prst="rect">
+            <a:avLst/>
+          </a:prstGeom>
+          <a:noFill/>
+        </p:spPr>
+        <p:txBody>
+          <a:bodyPr wrap="none">
+            <a:spAutoFit/>
+          </a:bodyPr>
+          <a:lstStyle/>
+          <a:p>
+            <a:r>
+              <a:rPr sz="1400" b="1">
+                <a:solidFill>
+                  <a:srgbClr val="203044"/>
+                </a:solidFill>
+                <a:latin typeface="Aptos"/>
+              </a:rPr>
+              <a:t>Short-term</a:t>
+            </a:r>
+          </a:p>
+          <a:p>
+            <a:pPr>
+              <a:spcBef>
+                <a:spcPts val="600"/>
+              </a:spcBef>
+              <a:defRPr sz="1100">
+                <a:solidFill>
+                  <a:srgbClr val="465260"/>
+                </a:solidFill>
+                <a:latin typeface="Aptos"/>
+              </a:defRPr>
+            </a:pPr>
+            <a:r>
+              <a:t>Implement oracle selector mode</a:t>
+            </a:r>
+          </a:p>
+          <a:p>
+            <a:pPr>
+              <a:spcBef>
+                <a:spcPts val="600"/>
+              </a:spcBef>
+              <a:defRPr sz="1100">
+                <a:solidFill>
+                  <a:srgbClr val="465260"/>
+                </a:solidFill>
+                <a:latin typeface="Aptos"/>
+              </a:defRPr>
+            </a:pPr>
+            <a:r>
+              <a:t>Run oracle vs LoRA on same prompts/seeds</a:t>
+            </a:r>
+          </a:p>
+          <a:p>
+            <a:pPr>
+              <a:spcBef>
+                <a:spcPts val="600"/>
+              </a:spcBef>
+              <a:defRPr sz="1100">
+                <a:solidFill>
+                  <a:srgbClr val="465260"/>
+                </a:solidFill>
+                <a:latin typeface="Aptos"/>
+              </a:defRPr>
+            </a:pPr>
+            <a:r>
+              <a:t>Summarize hit_any, mask size, reopen_changed</a:t>
+            </a:r>
+          </a:p>
+        </p:txBody>
+      </p:sp>
+      <p:sp>
+        <p:nvSpPr>
+          <p:cNvPr id="8" name="Rounded Rectangle 7"/>
+          <p:cNvSpPr/>
+          <p:nvPr/>
+        </p:nvSpPr>
+        <p:spPr>
+          <a:xfrm>
+            <a:off x="6309360" y="1325880"/>
+            <a:ext cx="5120640" cy="2011680"/>
+          </a:xfrm>
+          <a:prstGeom prst="roundRect">
+            <a:avLst/>
+          </a:prstGeom>
+          <a:solidFill>
+            <a:srgbClr val="FFFFFF"/>
+          </a:solidFill>
+          <a:ln w="10160">
+            <a:solidFill>
+              <a:srgbClr val="CDD3DB"/>
+            </a:solidFill>
+          </a:ln>
+        </p:spPr>
+        <p:style>
+          <a:lnRef idx="1">
+            <a:schemeClr val="accent1"/>
+          </a:lnRef>
+          <a:fillRef idx="3">
+            <a:schemeClr val="accent1"/>
+          </a:fillRef>
+          <a:effectRef idx="2">
+            <a:schemeClr val="accent1"/>
+          </a:effectRef>
+          <a:fontRef idx="minor">
+            <a:schemeClr val="lt1"/>
+          </a:fontRef>
+        </p:style>
+        <p:txBody>
+          <a:bodyPr rtlCol="0" anchor="ctr"/>
+          <a:lstStyle/>
+          <a:p>
+            <a:pPr algn="ctr"/>
+          </a:p>
+        </p:txBody>
+      </p:sp>
+      <p:sp>
+        <p:nvSpPr>
+          <p:cNvPr id="9" name="Rectangle 8"/>
+          <p:cNvSpPr/>
+          <p:nvPr/>
+        </p:nvSpPr>
+        <p:spPr>
+          <a:xfrm>
+            <a:off x="6309360" y="1325880"/>
+            <a:ext cx="73152" cy="2011680"/>
+          </a:xfrm>
+          <a:prstGeom prst="rect">
+            <a:avLst/>
+          </a:prstGeom>
+          <a:solidFill>
+            <a:srgbClr val="4E817C"/>
+          </a:solidFill>
+          <a:ln>
+            <a:noFill/>
+          </a:ln>
+        </p:spPr>
+        <p:style>
+          <a:lnRef idx="1">
+            <a:schemeClr val="accent1"/>
+          </a:lnRef>
+          <a:fillRef idx="3">
+            <a:schemeClr val="accent1"/>
+          </a:fillRef>
+          <a:effectRef idx="2">
+            <a:schemeClr val="accent1"/>
+          </a:effectRef>
+          <a:fontRef idx="minor">
+            <a:schemeClr val="lt1"/>
+          </a:fontRef>
+        </p:style>
+        <p:txBody>
+          <a:bodyPr rtlCol="0" anchor="ctr"/>
+          <a:lstStyle/>
+          <a:p>
+            <a:pPr algn="ctr"/>
+          </a:p>
+        </p:txBody>
+      </p:sp>
+      <p:sp>
+        <p:nvSpPr>
+          <p:cNvPr id="10" name="TextBox 9"/>
+          <p:cNvSpPr txBox="1"/>
+          <p:nvPr/>
+        </p:nvSpPr>
+        <p:spPr>
+          <a:xfrm>
+            <a:off x="6510528" y="1490472"/>
+            <a:ext cx="4736592" cy="1783080"/>
+          </a:xfrm>
+          <a:prstGeom prst="rect">
+            <a:avLst/>
+          </a:prstGeom>
+          <a:noFill/>
+        </p:spPr>
+        <p:txBody>
+          <a:bodyPr wrap="none">
+            <a:spAutoFit/>
+          </a:bodyPr>
+          <a:lstStyle/>
+          <a:p>
+            <a:r>
+              <a:rPr sz="1400" b="1">
+                <a:solidFill>
+                  <a:srgbClr val="203044"/>
+                </a:solidFill>
+                <a:latin typeface="Aptos"/>
+              </a:rPr>
+              <a:t>Image-space control</a:t>
+            </a:r>
+          </a:p>
+          <a:p>
+            <a:pPr>
+              <a:spcBef>
+                <a:spcPts val="600"/>
+              </a:spcBef>
+              <a:defRPr sz="1100">
+                <a:solidFill>
+                  <a:srgbClr val="465260"/>
+                </a:solidFill>
+                <a:latin typeface="Aptos"/>
+              </a:defRPr>
+            </a:pPr>
+            <a:r>
+              <a:t>Prototype external API evaluator on decoded corrupted images</a:t>
+            </a:r>
+          </a:p>
+          <a:p>
+            <a:pPr>
+              <a:spcBef>
+                <a:spcPts val="600"/>
+              </a:spcBef>
+              <a:defRPr sz="1100">
+                <a:solidFill>
+                  <a:srgbClr val="465260"/>
+                </a:solidFill>
+                <a:latin typeface="Aptos"/>
+              </a:defRPr>
+            </a:pPr>
+            <a:r>
+              <a:t>Keep outputs clearly labeled as teacher/API branch</a:t>
+            </a:r>
+          </a:p>
+          <a:p>
+            <a:pPr>
+              <a:spcBef>
+                <a:spcPts val="600"/>
+              </a:spcBef>
+              <a:defRPr sz="1100">
+                <a:solidFill>
+                  <a:srgbClr val="465260"/>
+                </a:solidFill>
+                <a:latin typeface="Aptos"/>
+              </a:defRPr>
+            </a:pPr>
+            <a:r>
+              <a:t>Do not mix teacher labels into Stage-3 self-supervision</a:t>
+            </a:r>
+          </a:p>
+        </p:txBody>
+      </p:sp>
+      <p:sp>
+        <p:nvSpPr>
+          <p:cNvPr id="11" name="Rounded Rectangle 10"/>
+          <p:cNvSpPr/>
+          <p:nvPr/>
+        </p:nvSpPr>
+        <p:spPr>
+          <a:xfrm>
+            <a:off x="731520" y="3794760"/>
+            <a:ext cx="10698480" cy="1325880"/>
+          </a:xfrm>
+          <a:prstGeom prst="roundRect">
+            <a:avLst/>
+          </a:prstGeom>
+          <a:solidFill>
+            <a:srgbClr val="FFFFFF"/>
+          </a:solidFill>
+          <a:ln w="10160">
+            <a:solidFill>
+              <a:srgbClr val="CDD3DB"/>
+            </a:solidFill>
+          </a:ln>
+        </p:spPr>
+        <p:style>
+          <a:lnRef idx="1">
+            <a:schemeClr val="accent1"/>
+          </a:lnRef>
+          <a:fillRef idx="3">
+            <a:schemeClr val="accent1"/>
+          </a:fillRef>
+          <a:effectRef idx="2">
+            <a:schemeClr val="accent1"/>
+          </a:effectRef>
+          <a:fontRef idx="minor">
+            <a:schemeClr val="lt1"/>
+          </a:fontRef>
+        </p:style>
+        <p:txBody>
+          <a:bodyPr rtlCol="0" anchor="ctr"/>
+          <a:lstStyle/>
+          <a:p>
+            <a:pPr algn="ctr"/>
+          </a:p>
+        </p:txBody>
+      </p:sp>
+      <p:sp>
+        <p:nvSpPr>
+          <p:cNvPr id="12" name="Rectangle 11"/>
+          <p:cNvSpPr/>
+          <p:nvPr/>
+        </p:nvSpPr>
+        <p:spPr>
+          <a:xfrm>
+            <a:off x="731520" y="3794760"/>
+            <a:ext cx="73152" cy="1325880"/>
+          </a:xfrm>
+          <a:prstGeom prst="rect">
+            <a:avLst/>
+          </a:prstGeom>
+          <a:solidFill>
+            <a:srgbClr val="9C7A3F"/>
+          </a:solidFill>
+          <a:ln>
+            <a:noFill/>
+          </a:ln>
+        </p:spPr>
+        <p:style>
+          <a:lnRef idx="1">
+            <a:schemeClr val="accent1"/>
+          </a:lnRef>
+          <a:fillRef idx="3">
+            <a:schemeClr val="accent1"/>
+          </a:fillRef>
+          <a:effectRef idx="2">
+            <a:schemeClr val="accent1"/>
+          </a:effectRef>
+          <a:fontRef idx="minor">
+            <a:schemeClr val="lt1"/>
+          </a:fontRef>
+        </p:style>
+        <p:txBody>
+          <a:bodyPr rtlCol="0" anchor="ctr"/>
+          <a:lstStyle/>
+          <a:p>
+            <a:pPr algn="ctr"/>
+          </a:p>
+        </p:txBody>
+      </p:sp>
+      <p:sp>
+        <p:nvSpPr>
+          <p:cNvPr id="13" name="TextBox 12"/>
+          <p:cNvSpPr txBox="1"/>
+          <p:nvPr/>
+        </p:nvSpPr>
+        <p:spPr>
+          <a:xfrm>
+            <a:off x="932688" y="3959352"/>
+            <a:ext cx="10314432" cy="1097280"/>
+          </a:xfrm>
+          <a:prstGeom prst="rect">
+            <a:avLst/>
+          </a:prstGeom>
+          <a:noFill/>
+        </p:spPr>
+        <p:txBody>
+          <a:bodyPr wrap="none">
+            <a:spAutoFit/>
+          </a:bodyPr>
+          <a:lstStyle/>
+          <a:p>
+            <a:r>
+              <a:rPr sz="1400" b="1">
+                <a:solidFill>
+                  <a:srgbClr val="203044"/>
+                </a:solidFill>
+                <a:latin typeface="Aptos"/>
+              </a:rPr>
+              <a:t>Training implication</a:t>
+            </a:r>
+          </a:p>
+          <a:p>
+            <a:pPr>
+              <a:spcBef>
+                <a:spcPts val="600"/>
+              </a:spcBef>
+              <a:defRPr sz="1100">
+                <a:solidFill>
+                  <a:srgbClr val="465260"/>
+                </a:solidFill>
+                <a:latin typeface="Aptos"/>
+              </a:defRPr>
+            </a:pPr>
+            <a:r>
+              <a:t>Only retrain native localizer after the oracle branch shows the reopen mechanism can produce meaningful improvements.</a:t>
+            </a:r>
+          </a:p>
+        </p:txBody>
+      </p:sp>
+      <p:sp>
+        <p:nvSpPr>
+          <p:cNvPr id="14" name="TextBox 13"/>
+          <p:cNvSpPr txBox="1"/>
+          <p:nvPr/>
+        </p:nvSpPr>
+        <p:spPr>
+          <a:xfrm>
+            <a:off x="502920" y="6446520"/>
+            <a:ext cx="10789920" cy="228600"/>
+          </a:xfrm>
+          <a:prstGeom prst="rect">
+            <a:avLst/>
+          </a:prstGeom>
+          <a:noFill/>
+        </p:spPr>
+        <p:txBody>
+          <a:bodyPr wrap="none">
+            <a:spAutoFit/>
+          </a:bodyPr>
+          <a:lstStyle/>
+          <a:p>
+            <a:pPr algn="l"/>
+            <a:r>
+              <a:rPr sz="800" b="0">
+                <a:solidFill>
+                  <a:srgbClr val="697380"/>
+                </a:solidFill>
+                <a:latin typeface="Aptos"/>
+              </a:rPr>
+              <a:t>ASCR Stage 3 weekly update | Page 13</a:t>
+            </a:r>
+          </a:p>
+        </p:txBody>
+      </p:sp>
+    </p:spTree>
+  </p:cSld>
+  <p:clrMapOvr>
+    <a:masterClrMapping/>
+  </p:clrMapOvr>
+</p:sld>
+</file>
+
+<file path=ppt/slides/slide14.xml><?xml version="1.0" encoding="utf-8"?>
+<p:sld xmlns:a="http://schemas.openxmlformats.org/drawingml/2006/main" xmlns:p="http://schemas.openxmlformats.org/presentationml/2006/main" xmlns:r="http://schemas.openxmlformats.org/officeDocument/2006/relationships">
+  <p:cSld>
+    <p:bg>
+      <p:bgPr>
+        <a:solidFill>
+          <a:srgbClr val="F7F8FA"/>
+        </a:solidFill>
+        <a:effectLst/>
+      </p:bgPr>
+    </p:bg>
+    <p:spTree>
+      <p:nvGrpSpPr>
+        <p:cNvPr id="1" name=""/>
+        <p:cNvGrpSpPr/>
+        <p:nvPr/>
+      </p:nvGrpSpPr>
+      <p:grpSpPr/>
+      <p:sp>
+        <p:nvSpPr>
+          <p:cNvPr id="2" name="TextBox 1"/>
+          <p:cNvSpPr txBox="1"/>
+          <p:nvPr/>
+        </p:nvSpPr>
+        <p:spPr>
+          <a:xfrm>
+            <a:off x="502920" y="320040"/>
+            <a:ext cx="11155680" cy="548640"/>
+          </a:xfrm>
+          <a:prstGeom prst="rect">
+            <a:avLst/>
+          </a:prstGeom>
+          <a:noFill/>
+        </p:spPr>
+        <p:txBody>
+          <a:bodyPr wrap="none">
+            <a:spAutoFit/>
+          </a:bodyPr>
+          <a:lstStyle/>
+          <a:p>
+            <a:pPr algn="l"/>
+            <a:r>
+              <a:rPr sz="2400" b="1">
+                <a:solidFill>
+                  <a:srgbClr val="203044"/>
+                </a:solidFill>
+                <a:latin typeface="Aptos"/>
+              </a:rPr>
+              <a:t>Evidence Sources / 依据文件</a:t>
+            </a:r>
+          </a:p>
+        </p:txBody>
+      </p:sp>
+      <p:sp>
+        <p:nvSpPr>
+          <p:cNvPr id="3" name="TextBox 2"/>
+          <p:cNvSpPr txBox="1"/>
+          <p:nvPr/>
+        </p:nvSpPr>
+        <p:spPr>
+          <a:xfrm>
+            <a:off x="521207" y="804672"/>
+            <a:ext cx="11064240" cy="292608"/>
+          </a:xfrm>
+          <a:prstGeom prst="rect">
+            <a:avLst/>
+          </a:prstGeom>
+          <a:noFill/>
+        </p:spPr>
+        <p:txBody>
+          <a:bodyPr wrap="none">
+            <a:spAutoFit/>
+          </a:bodyPr>
+          <a:lstStyle/>
+          <a:p>
+            <a:pPr algn="l"/>
+            <a:r>
+              <a:rPr sz="1000" b="0">
+                <a:solidFill>
+                  <a:srgbClr val="697380"/>
+                </a:solidFill>
+                <a:latin typeface="Aptos"/>
+              </a:rPr>
+              <a:t>Repository files used to avoid unsupported claims</a:t>
+            </a:r>
+          </a:p>
+        </p:txBody>
+      </p:sp>
+      <p:sp>
+        <p:nvSpPr>
+          <p:cNvPr id="4" name="Rectangle 3"/>
+          <p:cNvSpPr/>
+          <p:nvPr/>
+        </p:nvSpPr>
+        <p:spPr>
+          <a:xfrm>
+            <a:off x="502920" y="1097280"/>
+            <a:ext cx="11155680" cy="18288"/>
+          </a:xfrm>
+          <a:prstGeom prst="rect">
+            <a:avLst/>
+          </a:prstGeom>
+          <a:solidFill>
+            <a:srgbClr val="CDD3DB"/>
+          </a:solidFill>
+          <a:ln>
+            <a:noFill/>
+          </a:ln>
+        </p:spPr>
+        <p:style>
+          <a:lnRef idx="1">
+            <a:schemeClr val="accent1"/>
+          </a:lnRef>
+          <a:fillRef idx="3">
+            <a:schemeClr val="accent1"/>
+          </a:fillRef>
+          <a:effectRef idx="2">
+            <a:schemeClr val="accent1"/>
+          </a:effectRef>
+          <a:fontRef idx="minor">
+            <a:schemeClr val="lt1"/>
+          </a:fontRef>
+        </p:style>
+        <p:txBody>
+          <a:bodyPr rtlCol="0" anchor="ctr"/>
+          <a:lstStyle/>
+          <a:p>
+            <a:pPr algn="ctr"/>
+          </a:p>
+        </p:txBody>
+      </p:sp>
+      <p:sp>
+        <p:nvSpPr>
+          <p:cNvPr id="5" name="Rounded Rectangle 4"/>
+          <p:cNvSpPr/>
+          <p:nvPr/>
+        </p:nvSpPr>
+        <p:spPr>
+          <a:xfrm>
+            <a:off x="731520" y="1325880"/>
+            <a:ext cx="10698480" cy="3886200"/>
+          </a:xfrm>
+          <a:prstGeom prst="roundRect">
+            <a:avLst/>
+          </a:prstGeom>
+          <a:solidFill>
+            <a:srgbClr val="FFFFFF"/>
+          </a:solidFill>
+          <a:ln w="10160">
+            <a:solidFill>
+              <a:srgbClr val="CDD3DB"/>
+            </a:solidFill>
+          </a:ln>
+        </p:spPr>
+        <p:style>
+          <a:lnRef idx="1">
+            <a:schemeClr val="accent1"/>
+          </a:lnRef>
+          <a:fillRef idx="3">
+            <a:schemeClr val="accent1"/>
+          </a:fillRef>
+          <a:effectRef idx="2">
+            <a:schemeClr val="accent1"/>
+          </a:effectRef>
+          <a:fontRef idx="minor">
+            <a:schemeClr val="lt1"/>
+          </a:fontRef>
+        </p:style>
+        <p:txBody>
+          <a:bodyPr rtlCol="0" anchor="ctr"/>
+          <a:lstStyle/>
+          <a:p>
+            <a:pPr algn="ctr"/>
+          </a:p>
+        </p:txBody>
+      </p:sp>
+      <p:sp>
+        <p:nvSpPr>
+          <p:cNvPr id="6" name="Rectangle 5"/>
+          <p:cNvSpPr/>
+          <p:nvPr/>
+        </p:nvSpPr>
+        <p:spPr>
+          <a:xfrm>
+            <a:off x="731520" y="1325880"/>
             <a:ext cx="73152" cy="3886200"/>
           </a:xfrm>
           <a:prstGeom prst="rect">
@@ -6259,6 +6928,38 @@
               <a:t>configs/stage4/self_corrupt/mmu_sft_token_repair_8x8.yaml</a:t>
             </a:r>
           </a:p>
+          <a:p>
+            <a:pPr>
+              <a:spcBef>
+                <a:spcPts val="600"/>
+              </a:spcBef>
+              <a:defRPr sz="1100">
+                <a:solidFill>
+                  <a:srgbClr val="465260"/>
+                </a:solidFill>
+                <a:latin typeface="Aptos"/>
+              </a:defRPr>
+            </a:pPr>
+            <a:r>
+              <a:t>outputs/stage5_self_corrupt/token_repair_8x8_bench2_peftfix_1h/summary.json</a:t>
+            </a:r>
+          </a:p>
+          <a:p>
+            <a:pPr>
+              <a:spcBef>
+                <a:spcPts val="600"/>
+              </a:spcBef>
+              <a:defRPr sz="1100">
+                <a:solidFill>
+                  <a:srgbClr val="465260"/>
+                </a:solidFill>
+                <a:latin typeface="Aptos"/>
+              </a:defRPr>
+            </a:pPr>
+            <a:r>
+              <a:t>outputs/stage5_self_corrupt/token_repair_8x8_bench2_peftfix_1h/comparison/stage5_loop_comparison.json</a:t>
+            </a:r>
+          </a:p>
         </p:txBody>
       </p:sp>
       <p:sp>
@@ -6291,7 +6992,7 @@
                 </a:solidFill>
                 <a:latin typeface="Aptos"/>
               </a:rPr>
-              <a:t>ASCR Stage 3 weekly update | Page 13</a:t>
+              <a:t>ASCR Stage 3 weekly update | Page 14</a:t>
             </a:r>
           </a:p>
         </p:txBody>
@@ -7649,7 +8350,7 @@
             <a:avLst/>
           </a:prstGeom>
           <a:solidFill>
-            <a:srgbClr val="465260"/>
+            <a:srgbClr val="588760"/>
           </a:solidFill>
           <a:ln>
             <a:noFill/>
@@ -7682,7 +8383,7 @@
                 <a:latin typeface="Aptos"/>
               </a:rPr>
               <a:t>P5
-ASCR loop</a:t>
+Loop wired</a:t>
             </a:r>
           </a:p>
         </p:txBody>
@@ -8006,7 +8707,7 @@
               </a:defRPr>
             </a:pPr>
             <a:r>
-              <a:t>P4 repair_cells SFT + LoRA pipeline</a:t>
+              <a:t>P4 repair_cells LoRA is runnable</a:t>
             </a:r>
           </a:p>
           <a:p>
@@ -8022,7 +8723,7 @@
               </a:defRPr>
             </a:pPr>
             <a:r>
-              <a:t>1024px H200/L40S training profiles</a:t>
+              <a:t>Format still unstable</a:t>
             </a:r>
           </a:p>
           <a:p>
@@ -8038,7 +8739,7 @@
               </a:defRPr>
             </a:pPr>
             <a:r>
-              <a:t>Parse-rate-first evaluation</a:t>
+              <a:t>Localization quality is the blocker</a:t>
             </a:r>
           </a:p>
         </p:txBody>
@@ -8176,7 +8877,7 @@
               </a:defRPr>
             </a:pPr>
             <a:r>
-              <a:t>P5 loop integration after useful selector</a:t>
+              <a:t>P5 loop engineering verified</a:t>
             </a:r>
           </a:p>
           <a:p>
@@ -8192,7 +8893,7 @@
               </a:defRPr>
             </a:pPr>
             <a:r>
-              <a:t>Synthetic localization + image-quality evaluation</a:t>
+              <a:t>Run oracle upper bound</a:t>
             </a:r>
           </a:p>
           <a:p>
@@ -8208,7 +8909,7 @@
               </a:defRPr>
             </a:pPr>
             <a:r>
-              <a:t>No claims beyond current evidence</a:t>
+              <a:t>Compare image-space teacher loop</a:t>
             </a:r>
           </a:p>
         </p:txBody>

</xml_diff>